<commit_message>
Fix SCD2 same-day duplicate bug; build out interview deck with real captures
Found while capturing real validation output for the deck: a same-day
duplicate salary-history entry broke dim_employee's interval math for one
employee (EMP0084), passing the overlap check but failing the gap check.
Fixed in data_model.sql by collapsing same-day history rows to their
terminal state before versioning; warehouse rebuilt (2,231 rows, was
2,232). Updated ASSUMPTIONS.md, both VALIDATION_EVIDENCE.md files,
SUBMISSION_NOTES.md, and project_docs/01_foundations.md to match, and
corrected an earlier doc that had misattributed this to an unrelated data
conflict.

Also filled in Presight_Data_Project.pptx with real captures: live
Airflow/Kafka UI screenshots, real DuckDB validation output, a real
docker run + DQ report capture, and a bar chart for the query-optimisation
benchmark, replacing the placeholder boxes left in the deck.
</commit_message>
<xml_diff>
--- a/solutions/submissions/baiju_mohan/Presight_Data_Project.pptx
+++ b/solutions/submissions/baiju_mohan/Presight_Data_Project.pptx
@@ -3616,79 +3616,6 @@
       </p:sp>
       <p:sp>
         <p:nvSpPr>
-          <p:cNvPr id="5" name="Rectangle 4"/>
-          <p:cNvSpPr/>
-          <p:nvPr/>
-        </p:nvSpPr>
-        <p:spPr>
-          <a:xfrm>
-            <a:off x="5074920" y="1600200"/>
-            <a:ext cx="6172200" cy="4160520"/>
-          </a:xfrm>
-          <a:prstGeom prst="rect">
-            <a:avLst/>
-          </a:prstGeom>
-          <a:solidFill>
-            <a:srgbClr val="EEEFF3"/>
-          </a:solidFill>
-          <a:ln w="15875">
-            <a:solidFill>
-              <a:srgbClr val="878DA0"/>
-            </a:solidFill>
-            <a:prstDash val="dash"/>
-          </a:ln>
-          <a:effectLst/>
-        </p:spPr>
-        <p:style>
-          <a:lnRef idx="1">
-            <a:schemeClr val="accent1"/>
-          </a:lnRef>
-          <a:fillRef idx="3">
-            <a:schemeClr val="accent1"/>
-          </a:fillRef>
-          <a:effectRef idx="2">
-            <a:schemeClr val="accent1"/>
-          </a:effectRef>
-          <a:fontRef idx="minor">
-            <a:schemeClr val="lt1"/>
-          </a:fontRef>
-        </p:style>
-        <p:txBody>
-          <a:bodyPr rtlCol="0" anchor="ctr" wrap="square"/>
-          <a:lstStyle/>
-          <a:p>
-            <a:pPr algn="ctr"/>
-            <a:r>
-              <a:rPr sz="3000" b="0" i="0">
-                <a:solidFill>
-                  <a:srgbClr val="878DA0"/>
-                </a:solidFill>
-                <a:latin typeface="Calibri"/>
-              </a:rPr>
-              <a:t>▢</a:t>
-            </a:r>
-          </a:p>
-          <a:p>
-            <a:pPr algn="ctr">
-              <a:spcBef>
-                <a:spcPts val="800"/>
-              </a:spcBef>
-            </a:pPr>
-            <a:r>
-              <a:rPr sz="1300" b="0" i="1">
-                <a:solidFill>
-                  <a:srgbClr val="878DA0"/>
-                </a:solidFill>
-                <a:latin typeface="Calibri"/>
-              </a:rPr>
-              <a:t>Insert screenshot here
-(e.g. Airflow DAG graph view / Kafka UI topics)</a:t>
-            </a:r>
-          </a:p>
-        </p:txBody>
-      </p:sp>
-      <p:sp>
-        <p:nvSpPr>
           <p:cNvPr id="6" name="TextBox 5"/>
           <p:cNvSpPr txBox="1"/>
           <p:nvPr/>
@@ -3813,6 +3740,30 @@
           </a:p>
         </p:txBody>
       </p:sp>
+      <p:pic>
+        <p:nvPicPr>
+          <p:cNvPr id="9" name="Picture 8" descr="pillar3_composite.png"/>
+          <p:cNvPicPr>
+            <a:picLocks noChangeAspect="1"/>
+          </p:cNvPicPr>
+          <p:nvPr/>
+        </p:nvPicPr>
+        <p:blipFill>
+          <a:blip r:embed="rId2"/>
+          <a:stretch>
+            <a:fillRect/>
+          </a:stretch>
+        </p:blipFill>
+        <p:spPr>
+          <a:xfrm>
+            <a:off x="5074920" y="1600200"/>
+            <a:ext cx="6172200" cy="4160520"/>
+          </a:xfrm>
+          <a:prstGeom prst="rect">
+            <a:avLst/>
+          </a:prstGeom>
+        </p:spPr>
+      </p:pic>
     </p:spTree>
   </p:cSld>
   <p:clrMapOvr>
@@ -4473,79 +4424,6 @@
       </p:sp>
       <p:sp>
         <p:nvSpPr>
-          <p:cNvPr id="5" name="Rectangle 4"/>
-          <p:cNvSpPr/>
-          <p:nvPr/>
-        </p:nvSpPr>
-        <p:spPr>
-          <a:xfrm>
-            <a:off x="5074920" y="1600200"/>
-            <a:ext cx="6172200" cy="4160520"/>
-          </a:xfrm>
-          <a:prstGeom prst="rect">
-            <a:avLst/>
-          </a:prstGeom>
-          <a:solidFill>
-            <a:srgbClr val="EEEFF3"/>
-          </a:solidFill>
-          <a:ln w="15875">
-            <a:solidFill>
-              <a:srgbClr val="878DA0"/>
-            </a:solidFill>
-            <a:prstDash val="dash"/>
-          </a:ln>
-          <a:effectLst/>
-        </p:spPr>
-        <p:style>
-          <a:lnRef idx="1">
-            <a:schemeClr val="accent1"/>
-          </a:lnRef>
-          <a:fillRef idx="3">
-            <a:schemeClr val="accent1"/>
-          </a:fillRef>
-          <a:effectRef idx="2">
-            <a:schemeClr val="accent1"/>
-          </a:effectRef>
-          <a:fontRef idx="minor">
-            <a:schemeClr val="lt1"/>
-          </a:fontRef>
-        </p:style>
-        <p:txBody>
-          <a:bodyPr rtlCol="0" anchor="ctr" wrap="square"/>
-          <a:lstStyle/>
-          <a:p>
-            <a:pPr algn="ctr"/>
-            <a:r>
-              <a:rPr sz="3000" b="0" i="0">
-                <a:solidFill>
-                  <a:srgbClr val="878DA0"/>
-                </a:solidFill>
-                <a:latin typeface="Calibri"/>
-              </a:rPr>
-              <a:t>▢</a:t>
-            </a:r>
-          </a:p>
-          <a:p>
-            <a:pPr algn="ctr">
-              <a:spcBef>
-                <a:spcPts val="800"/>
-              </a:spcBef>
-            </a:pPr>
-            <a:r>
-              <a:rPr sz="1300" b="0" i="1">
-                <a:solidFill>
-                  <a:srgbClr val="878DA0"/>
-                </a:solidFill>
-                <a:latin typeface="Calibri"/>
-              </a:rPr>
-              <a:t>Insert screenshot here
-(e.g. docker build/run output, or a DQ report excerpt)</a:t>
-            </a:r>
-          </a:p>
-        </p:txBody>
-      </p:sp>
-      <p:sp>
-        <p:nvSpPr>
           <p:cNvPr id="6" name="TextBox 5"/>
           <p:cNvSpPr txBox="1"/>
           <p:nvPr/>
@@ -4670,6 +4548,30 @@
           </a:p>
         </p:txBody>
       </p:sp>
+      <p:pic>
+        <p:nvPicPr>
+          <p:cNvPr id="9" name="Picture 8" descr="pillar4_capture.png"/>
+          <p:cNvPicPr>
+            <a:picLocks noChangeAspect="1"/>
+          </p:cNvPicPr>
+          <p:nvPr/>
+        </p:nvPicPr>
+        <p:blipFill>
+          <a:blip r:embed="rId2"/>
+          <a:stretch>
+            <a:fillRect/>
+          </a:stretch>
+        </p:blipFill>
+        <p:spPr>
+          <a:xfrm>
+            <a:off x="5074920" y="1600200"/>
+            <a:ext cx="6172200" cy="4160520"/>
+          </a:xfrm>
+          <a:prstGeom prst="rect">
+            <a:avLst/>
+          </a:prstGeom>
+        </p:spPr>
+      </p:pic>
     </p:spTree>
   </p:cSld>
   <p:clrMapOvr>
@@ -4854,6 +4756,22 @@
               <a:t>Once dim_employee versions salary/role/level, fact_transactions resolves "who approved this, and what was true about them then" via a point-in-time BETWEEN match — everything needing historical accuracy depends on this.</a:t>
             </a:r>
           </a:p>
+          <a:p>
+            <a:pPr>
+              <a:spcBef>
+                <a:spcPts val="300"/>
+              </a:spcBef>
+            </a:pPr>
+            <a:r>
+              <a:rPr sz="1050" i="1" b="0">
+                <a:solidFill>
+                  <a:srgbClr val="4A5063"/>
+                </a:solidFill>
+                <a:latin typeface="Calibri"/>
+              </a:rPr>
+              <a:t>Update: a real fix, not a hypothetical. Two same-day salary changes broke this exact interval math for one employee — Q3’s overlap check missed it, Q5’s gap check caught it. Found via re-running validation, not code review; fixed by collapsing same-day changes to their final state before versioning.</a:t>
+            </a:r>
+          </a:p>
         </p:txBody>
       </p:sp>
       <p:sp>
@@ -5309,7 +5227,7 @@
                 </a:solidFill>
                 <a:latin typeface="Calibri"/>
               </a:rPr>
-              <a:t>Four real bugs, none visible from reading the code — only found by running the pipeline against real data and real infrastructure.</a:t>
+              <a:t>Five real bugs, none visible from reading the code — only found by running the pipeline against real data and real infrastructure.</a:t>
             </a:r>
           </a:p>
         </p:txBody>
@@ -5323,7 +5241,7 @@
         <p:spPr>
           <a:xfrm>
             <a:off x="640080" y="2011680"/>
-            <a:ext cx="5166360" cy="1920240"/>
+            <a:ext cx="3459449" cy="1920240"/>
           </a:xfrm>
           <a:prstGeom prst="roundRect">
             <a:avLst>
@@ -5360,7 +5278,7 @@
           <a:p>
             <a:pPr algn="l"/>
             <a:r>
-              <a:rPr sz="950" b="1" i="0">
+              <a:rPr sz="850" b="1" i="0">
                 <a:solidFill>
                   <a:srgbClr val="878DA0"/>
                 </a:solidFill>
@@ -5376,7 +5294,7 @@
               </a:spcBef>
             </a:pPr>
             <a:r>
-              <a:rPr sz="1300" b="1" i="0">
+              <a:rPr sz="1150" b="1" i="0">
                 <a:solidFill>
                   <a:srgbClr val="171A24"/>
                 </a:solidFill>
@@ -5392,7 +5310,7 @@
               </a:spcBef>
             </a:pPr>
             <a:r>
-              <a:rPr sz="1080" b="0" i="0">
+              <a:rPr sz="950" b="0" i="0">
                 <a:solidFill>
                   <a:srgbClr val="4A5063"/>
                 </a:solidFill>
@@ -5411,8 +5329,8 @@
         </p:nvSpPr>
         <p:spPr>
           <a:xfrm>
-            <a:off x="5806440" y="2011680"/>
-            <a:ext cx="5486400" cy="1920240"/>
+            <a:off x="4236689" y="2011680"/>
+            <a:ext cx="3459449" cy="1920240"/>
           </a:xfrm>
           <a:prstGeom prst="roundRect">
             <a:avLst>
@@ -5449,64 +5367,64 @@
           <a:p>
             <a:pPr algn="l"/>
             <a:r>
+              <a:rPr sz="850" b="1" i="0">
+                <a:solidFill>
+                  <a:srgbClr val="878DA0"/>
+                </a:solidFill>
+                <a:latin typeface="Consolas"/>
+              </a:rPr>
+              <a:t>PILLAR 3 · SPARK</a:t>
+            </a:r>
+          </a:p>
+          <a:p>
+            <a:pPr>
+              <a:spcBef>
+                <a:spcPts val="300"/>
+              </a:spcBef>
+            </a:pPr>
+            <a:r>
+              <a:rPr sz="1150" b="1" i="0">
+                <a:solidFill>
+                  <a:srgbClr val="171A24"/>
+                </a:solidFill>
+                <a:latin typeface="Calibri"/>
+              </a:rPr>
+              <a:t>Escalations resolved in −7,708 hours</a:t>
+            </a:r>
+          </a:p>
+          <a:p>
+            <a:pPr>
+              <a:spcBef>
+                <a:spcPts val="400"/>
+              </a:spcBef>
+            </a:pPr>
+            <a:r>
+              <a:rPr sz="950" b="0" i="0">
+                <a:solidFill>
+                  <a:srgbClr val="4A5063"/>
+                </a:solidFill>
+                <a:latin typeface="Calibri"/>
+              </a:rPr>
+              <a:t>Root cause: "raised"/"resolved" events matched by position, not time.</a:t>
+            </a:r>
+          </a:p>
+          <a:p>
+            <a:pPr>
+              <a:spcBef>
+                <a:spcPts val="600"/>
+              </a:spcBef>
+            </a:pPr>
+            <a:r>
               <a:rPr sz="950" b="1" i="0">
                 <a:solidFill>
-                  <a:srgbClr val="878DA0"/>
+                  <a:srgbClr val="2E7D46"/>
                 </a:solidFill>
                 <a:latin typeface="Consolas"/>
               </a:rPr>
-              <a:t>PILLAR 3 · SPARK</a:t>
-            </a:r>
-          </a:p>
-          <a:p>
-            <a:pPr>
-              <a:spcBef>
-                <a:spcPts val="300"/>
-              </a:spcBef>
-            </a:pPr>
-            <a:r>
-              <a:rPr sz="1300" b="1" i="0">
-                <a:solidFill>
-                  <a:srgbClr val="171A24"/>
-                </a:solidFill>
-                <a:latin typeface="Calibri"/>
-              </a:rPr>
-              <a:t>Escalations resolved in −7,708 hours</a:t>
-            </a:r>
-          </a:p>
-          <a:p>
-            <a:pPr>
-              <a:spcBef>
-                <a:spcPts val="400"/>
-              </a:spcBef>
-            </a:pPr>
-            <a:r>
-              <a:rPr sz="1080" b="0" i="0">
-                <a:solidFill>
-                  <a:srgbClr val="4A5063"/>
-                </a:solidFill>
-                <a:latin typeface="Calibri"/>
-              </a:rPr>
-              <a:t>Root cause: "raised"/"resolved" events matched by position, not time.</a:t>
-            </a:r>
-          </a:p>
-          <a:p>
-            <a:pPr>
-              <a:spcBef>
-                <a:spcPts val="600"/>
-              </a:spcBef>
-            </a:pPr>
-            <a:r>
-              <a:rPr sz="950" b="1" i="0">
-                <a:solidFill>
-                  <a:srgbClr val="2E7D46"/>
-                </a:solidFill>
-                <a:latin typeface="Consolas"/>
-              </a:rPr>
               <a:t>FIX  </a:t>
             </a:r>
             <a:r>
-              <a:rPr sz="1050" b="0" i="0">
+              <a:rPr sz="950" b="0" i="0">
                 <a:solidFill>
                   <a:srgbClr val="4A5063"/>
                 </a:solidFill>
@@ -5525,8 +5443,8 @@
         </p:nvSpPr>
         <p:spPr>
           <a:xfrm>
-            <a:off x="640080" y="4114800"/>
-            <a:ext cx="5166360" cy="1874519"/>
+            <a:off x="7833298" y="2011680"/>
+            <a:ext cx="3459449" cy="1920240"/>
           </a:xfrm>
           <a:prstGeom prst="roundRect">
             <a:avLst>
@@ -5563,7 +5481,7 @@
           <a:p>
             <a:pPr algn="l"/>
             <a:r>
-              <a:rPr sz="950" b="1" i="0">
+              <a:rPr sz="850" b="1" i="0">
                 <a:solidFill>
                   <a:srgbClr val="878DA0"/>
                 </a:solidFill>
@@ -5579,7 +5497,7 @@
               </a:spcBef>
             </a:pPr>
             <a:r>
-              <a:rPr sz="1300" b="1" i="0">
+              <a:rPr sz="1150" b="1" i="0">
                 <a:solidFill>
                   <a:srgbClr val="171A24"/>
                 </a:solidFill>
@@ -5595,7 +5513,7 @@
               </a:spcBef>
             </a:pPr>
             <a:r>
-              <a:rPr sz="1080" b="0" i="0">
+              <a:rPr sz="950" b="0" i="0">
                 <a:solidFill>
                   <a:srgbClr val="4A5063"/>
                 </a:solidFill>
@@ -5614,8 +5532,8 @@
         </p:nvSpPr>
         <p:spPr>
           <a:xfrm>
-            <a:off x="5806440" y="4114800"/>
-            <a:ext cx="5486400" cy="1874519"/>
+            <a:off x="640080" y="4114800"/>
+            <a:ext cx="5166360" cy="1874519"/>
           </a:xfrm>
           <a:prstGeom prst="roundRect">
             <a:avLst>
@@ -5775,6 +5693,95 @@
                 <a:latin typeface="Consolas"/>
               </a:rPr>
               <a:t>14</a:t>
+            </a:r>
+          </a:p>
+        </p:txBody>
+      </p:sp>
+      <p:sp>
+        <p:nvSpPr>
+          <p:cNvPr id="8" name="Rounded Rectangle 7"/>
+          <p:cNvSpPr/>
+          <p:nvPr/>
+        </p:nvSpPr>
+        <p:spPr>
+          <a:xfrm>
+            <a:off x="5806440" y="4114800"/>
+            <a:ext cx="5486400" cy="1874519"/>
+          </a:xfrm>
+          <a:prstGeom prst="roundRect">
+            <a:avLst>
+              <a:gd name="adj" fmla="val 5000"/>
+            </a:avLst>
+          </a:prstGeom>
+          <a:solidFill>
+            <a:srgbClr val="FFFFFF"/>
+          </a:solidFill>
+          <a:ln w="9525">
+            <a:solidFill>
+              <a:srgbClr val="D9DBE4"/>
+            </a:solidFill>
+          </a:ln>
+          <a:effectLst/>
+        </p:spPr>
+        <p:style>
+          <a:lnRef idx="1">
+            <a:schemeClr val="accent1"/>
+          </a:lnRef>
+          <a:fillRef idx="3">
+            <a:schemeClr val="accent1"/>
+          </a:fillRef>
+          <a:effectRef idx="2">
+            <a:schemeClr val="accent1"/>
+          </a:effectRef>
+          <a:fontRef idx="minor">
+            <a:schemeClr val="lt1"/>
+          </a:fontRef>
+        </p:style>
+        <p:txBody>
+          <a:bodyPr rtlCol="0" anchor="ctr" wrap="square" lIns="201168" tIns="128016" rIns="182880" bIns="109728"/>
+          <a:lstStyle/>
+          <a:p>
+            <a:pPr algn="l"/>
+            <a:r>
+              <a:rPr sz="950" b="1" i="0">
+                <a:solidFill>
+                  <a:srgbClr val="878DA0"/>
+                </a:solidFill>
+                <a:latin typeface="Consolas"/>
+              </a:rPr>
+              <a:t>PILLAR 1 · FOUNDATIONS (SCD2)</a:t>
+            </a:r>
+          </a:p>
+          <a:p>
+            <a:pPr>
+              <a:spcBef>
+                <a:spcPts val="300"/>
+              </a:spcBef>
+            </a:pPr>
+            <a:r>
+              <a:rPr sz="1300" b="1" i="0">
+                <a:solidFill>
+                  <a:srgbClr val="171A24"/>
+                </a:solidFill>
+                <a:latin typeface="Calibri"/>
+              </a:rPr>
+              <a:t>Two salary changes, same day, broke the SCD2 interval math</a:t>
+            </a:r>
+          </a:p>
+          <a:p>
+            <a:pPr>
+              <a:spcBef>
+                <a:spcPts val="400"/>
+              </a:spcBef>
+            </a:pPr>
+            <a:r>
+              <a:rPr sz="1080" b="0" i="0">
+                <a:solidFill>
+                  <a:srgbClr val="4A5063"/>
+                </a:solidFill>
+                <a:latin typeface="Calibri"/>
+              </a:rPr>
+              <a:t>valid_to = next valid_from - 1 day assumed distinct dates; two same-day changes gave one version valid_to before its own valid_from. Q3 (overlap) missed it, Q5 (gap check) caught it — found re-running validation for this deck, not from re-reading the code.</a:t>
             </a:r>
           </a:p>
         </p:txBody>
@@ -7139,7 +7146,7 @@
                 </a:solidFill>
                 <a:latin typeface="Consolas"/>
               </a:rPr>
-              <a:t>2,232</a:t>
+              <a:t>2,231</a:t>
             </a:r>
           </a:p>
           <a:p>
@@ -7290,7 +7297,7 @@
                 </a:solidFill>
                 <a:latin typeface="Calibri"/>
               </a:rPr>
-              <a:t>every claim here was watched happen against real data and real infrastructure — not assumed to work because the code looked right. Four real bugs were found this way, none visible just from reading the code.</a:t>
+              <a:t>every claim here was watched happen against real data and real infrastructure — not assumed to work because the code looked right. Five real bugs were found this way, none visible just from reading the code.</a:t>
             </a:r>
           </a:p>
         </p:txBody>
@@ -9061,7 +9068,7 @@
                 </a:solidFill>
                 <a:latin typeface="Calibri"/>
               </a:rPr>
-              <a:t>—  1.2 — Star schema + dim_employee SCD2 → 2,232 versions. 0 duplicate-current rows, 0 overlapping periods.</a:t>
+              <a:t>—  1.2 — Star schema + dim_employee SCD2 → 2,231 versions. 0 duplicate-current rows, 0 overlapping periods.</a:t>
             </a:r>
           </a:p>
           <a:p>
@@ -9453,7 +9460,7 @@
                 </a:solidFill>
                 <a:latin typeface="Calibri"/>
               </a:rPr>
-              <a:t>2,232 versions · 0 duplicate-current · 0 overlaps</a:t>
+              <a:t>2,231 versions · 0 duplicate-current · 0 overlaps · 0 gaps</a:t>
             </a:r>
           </a:p>
           <a:p>
@@ -9492,79 +9499,6 @@
                 <a:latin typeface="Calibri"/>
               </a:rPr>
               <a:t>0.29s pipeline (target &lt;30s) — PASS</a:t>
-            </a:r>
-          </a:p>
-        </p:txBody>
-      </p:sp>
-      <p:sp>
-        <p:nvSpPr>
-          <p:cNvPr id="5" name="Rectangle 4"/>
-          <p:cNvSpPr/>
-          <p:nvPr/>
-        </p:nvSpPr>
-        <p:spPr>
-          <a:xfrm>
-            <a:off x="5074920" y="1600200"/>
-            <a:ext cx="6172200" cy="4160520"/>
-          </a:xfrm>
-          <a:prstGeom prst="rect">
-            <a:avLst/>
-          </a:prstGeom>
-          <a:solidFill>
-            <a:srgbClr val="EEEFF3"/>
-          </a:solidFill>
-          <a:ln w="15875">
-            <a:solidFill>
-              <a:srgbClr val="878DA0"/>
-            </a:solidFill>
-            <a:prstDash val="dash"/>
-          </a:ln>
-          <a:effectLst/>
-        </p:spPr>
-        <p:style>
-          <a:lnRef idx="1">
-            <a:schemeClr val="accent1"/>
-          </a:lnRef>
-          <a:fillRef idx="3">
-            <a:schemeClr val="accent1"/>
-          </a:fillRef>
-          <a:effectRef idx="2">
-            <a:schemeClr val="accent1"/>
-          </a:effectRef>
-          <a:fontRef idx="minor">
-            <a:schemeClr val="lt1"/>
-          </a:fontRef>
-        </p:style>
-        <p:txBody>
-          <a:bodyPr rtlCol="0" anchor="ctr" wrap="square"/>
-          <a:lstStyle/>
-          <a:p>
-            <a:pPr algn="ctr"/>
-            <a:r>
-              <a:rPr sz="3000" b="0" i="0">
-                <a:solidFill>
-                  <a:srgbClr val="878DA0"/>
-                </a:solidFill>
-                <a:latin typeface="Calibri"/>
-              </a:rPr>
-              <a:t>▢</a:t>
-            </a:r>
-          </a:p>
-          <a:p>
-            <a:pPr algn="ctr">
-              <a:spcBef>
-                <a:spcPts val="800"/>
-              </a:spcBef>
-            </a:pPr>
-            <a:r>
-              <a:rPr sz="1300" b="0" i="1">
-                <a:solidFill>
-                  <a:srgbClr val="878DA0"/>
-                </a:solidFill>
-                <a:latin typeface="Calibri"/>
-              </a:rPr>
-              <a:t>Insert screenshot here
-(e.g. dim_employee validation query result / DuckDB CLI)</a:t>
             </a:r>
           </a:p>
         </p:txBody>
@@ -9695,6 +9629,30 @@
           </a:p>
         </p:txBody>
       </p:sp>
+      <p:pic>
+        <p:nvPicPr>
+          <p:cNvPr id="9" name="Picture 8" descr="pillar1_capture.png"/>
+          <p:cNvPicPr>
+            <a:picLocks noChangeAspect="1"/>
+          </p:cNvPicPr>
+          <p:nvPr/>
+        </p:nvPicPr>
+        <p:blipFill>
+          <a:blip r:embed="rId2"/>
+          <a:stretch>
+            <a:fillRect/>
+          </a:stretch>
+        </p:blipFill>
+        <p:spPr>
+          <a:xfrm>
+            <a:off x="5074920" y="1600200"/>
+            <a:ext cx="6172200" cy="4160520"/>
+          </a:xfrm>
+          <a:prstGeom prst="rect">
+            <a:avLst/>
+          </a:prstGeom>
+        </p:spPr>
+      </p:pic>
     </p:spTree>
   </p:cSld>
   <p:clrMapOvr>
@@ -10418,8 +10376,8 @@
         </p:nvSpPr>
         <p:spPr>
           <a:xfrm>
-            <a:off x="5074920" y="1600200"/>
-            <a:ext cx="6172200" cy="4160520"/>
+            <a:off x="5074920" y="4003243"/>
+            <a:ext cx="6172200" cy="1757477"/>
           </a:xfrm>
           <a:prstGeom prst="rect">
             <a:avLst/>
@@ -10608,6 +10566,30 @@
           </a:p>
         </p:txBody>
       </p:sp>
+      <p:pic>
+        <p:nvPicPr>
+          <p:cNvPr id="9" name="Picture 8" descr="query_opt_chart.png"/>
+          <p:cNvPicPr>
+            <a:picLocks noChangeAspect="1"/>
+          </p:cNvPicPr>
+          <p:nvPr/>
+        </p:nvPicPr>
+        <p:blipFill>
+          <a:blip r:embed="rId2"/>
+          <a:stretch>
+            <a:fillRect/>
+          </a:stretch>
+        </p:blipFill>
+        <p:spPr>
+          <a:xfrm>
+            <a:off x="6487065" y="1600200"/>
+            <a:ext cx="3347909" cy="2256739"/>
+          </a:xfrm>
+          <a:prstGeom prst="rect">
+            <a:avLst/>
+          </a:prstGeom>
+        </p:spPr>
+      </p:pic>
     </p:spTree>
   </p:cSld>
   <p:clrMapOvr>

</xml_diff>